<commit_message>
Lösungsfolien markiert, Schüler-Handouts neu erzeugt (1.5.4)
- 18 weitere Folien mit [NUR LEHRKRAFT]: Folien, die Aufgaben des Arbeitsblatts,
  eine App-Aufgabe (Überliste Stufe 1) oder Spielrunden lösen (DS01, DS06–DS12, DS16)
- Handouts und Notizfassungen der neun Foliensätze neu, verzeichnis.json mit Hinweisen
- Doku: Kriterien in MATERIALIEN.md, Entscheidung festgehalten

Co-Authored-By: Claude Opus 5.5 <noreply@anthropic.com>
Claude-Session: https://claude.ai/code/session_01PWJnmHrzHBQwQfBgXDCh3C
</commit_message>
<xml_diff>
--- a/materials/pdf/original/DS01_Folien_Ein-Automat-hoert-zu.pptx
+++ b/materials/pdf/original/DS01_Folien_Ein-Automat-hoert-zu.pptx
@@ -126,12 +126,12 @@
   <p:extLst>
     <p:ext uri="{521415D9-36F7-43E2-AB2F-B90AF26B5E84}">
       <p14:sectionLst xmlns:p14="http://schemas.microsoft.com/office/powerpoint/2010/main">
-        <p14:section name="Start" id="{1e33a1a7-a2b6-aa9a-e0b0-7198b6f67185}">
+        <p14:section name="Start" id="{434ba10f-7c1f-88fd-5376-a8c5f8aed798}">
           <p14:sldIdLst>
             <p14:sldId id="256"/>
           </p14:sldIdLst>
         </p14:section>
-        <p14:section name="Einstieg" id="{93c9122b-5efe-e641-c765-47b15f65dc36}">
+        <p14:section name="Einstieg" id="{210b8ebf-a3fb-1795-873e-1d28e9978bc0}">
           <p14:sldIdLst>
             <p14:sldId id="257"/>
             <p14:sldId id="258"/>
@@ -141,7 +141,7 @@
             <p14:sldId id="262"/>
           </p14:sldIdLst>
         </p14:section>
-        <p14:section name="Erarbeitung" id="{4857b745-b759-0e3f-98df-1250d01b6f02}">
+        <p14:section name="Erarbeitung" id="{65ea9725-1adc-2af0-d1d7-40232804f6f4}">
           <p14:sldIdLst>
             <p14:sldId id="263"/>
             <p14:sldId id="264"/>
@@ -152,20 +152,20 @@
             <p14:sldId id="269"/>
           </p14:sldIdLst>
         </p14:section>
-        <p14:section name="Übung" id="{35368d37-62c5-cf23-3c18-6b4d095acc73}">
+        <p14:section name="Übung" id="{fd893216-abb0-70f0-2bf3-5dffc441dc71}">
           <p14:sldIdLst>
             <p14:sldId id="270"/>
             <p14:sldId id="271"/>
             <p14:sldId id="272"/>
           </p14:sldIdLst>
         </p14:section>
-        <p14:section name="Sicherung" id="{093f91f8-0260-b377-2ea5-50ccdf8f4e9e}">
+        <p14:section name="Sicherung" id="{dfa0ec2f-51e1-61fd-3e8b-c549592b5097}">
           <p14:sldIdLst>
             <p14:sldId id="273"/>
             <p14:sldId id="274"/>
           </p14:sldIdLst>
         </p14:section>
-        <p14:section name="Abschluss" id="{254eb838-5d50-c245-cf44-9ca51601d165}">
+        <p14:section name="Abschluss" id="{0f51d896-b48a-450c-7c0b-0364899836b6}">
           <p14:sldIdLst>
             <p14:sldId id="275"/>
           </p14:sldIdLst>
@@ -750,7 +750,7 @@
           <a:p>
             <a:r>
               <a:rPr lang="en-US" dirty="0"/>
-              <a:t>Wichtig: Entscheidend ist der Zustand NACH dem letzten Zeichen. Im Abitur: „Stellen Sie die Verarbeitung … dar“.</a:t>
+              <a:t>[NUR LEHRKRAFT] Wichtig: Entscheidend ist der Zustand NACH dem letzten Zeichen. Im Abitur: „Stellen Sie die Verarbeitung … dar“.</a:t>
             </a:r>
             <a:endParaRPr lang="en-US" dirty="0"/>
           </a:p>

</xml_diff>

<commit_message>
Lizenz: Code MIT, Unterrichtsmaterial CC BY-SA 4.0, Version 1.17.0
- LICENSE (MIT) für den Programmcode, materials/LIZENZ.md (CC BY-SA 4.0) für das Material
- Lizenzvermerk in den Fußzeilen aller Dokumente, Folien und Video-Folien
- alle Materialien und Plattform-PDFs neu erzeugt (verzeichnis.json mit neuen Größen)
- README, ENTSCHEIDUNGEN, MATERIALIEN, ROADMAP nachgezogen; package.json license MIT

Co-Authored-By: Claude Opus 5.5 <noreply@anthropic.com>
Claude-Session: https://claude.ai/code/session_01PWJnmHrzHBQwQfBgXDCh3C
</commit_message>
<xml_diff>
--- a/materials/pdf/original/DS01_Folien_Ein-Automat-hoert-zu.pptx
+++ b/materials/pdf/original/DS01_Folien_Ein-Automat-hoert-zu.pptx
@@ -126,12 +126,12 @@
   <p:extLst>
     <p:ext uri="{521415D9-36F7-43E2-AB2F-B90AF26B5E84}">
       <p14:sectionLst xmlns:p14="http://schemas.microsoft.com/office/powerpoint/2010/main">
-        <p14:section name="Start" id="{434ba10f-7c1f-88fd-5376-a8c5f8aed798}">
+        <p14:section name="Start" id="{9ae3e3ed-caaf-c61c-71c8-d25847aeadf9}">
           <p14:sldIdLst>
             <p14:sldId id="256"/>
           </p14:sldIdLst>
         </p14:section>
-        <p14:section name="Einstieg" id="{210b8ebf-a3fb-1795-873e-1d28e9978bc0}">
+        <p14:section name="Einstieg" id="{f5785a82-eb8a-5498-a70d-bfe1032d24dd}">
           <p14:sldIdLst>
             <p14:sldId id="257"/>
             <p14:sldId id="258"/>
@@ -141,7 +141,7 @@
             <p14:sldId id="262"/>
           </p14:sldIdLst>
         </p14:section>
-        <p14:section name="Erarbeitung" id="{65ea9725-1adc-2af0-d1d7-40232804f6f4}">
+        <p14:section name="Erarbeitung" id="{956e331a-3f3e-08b8-b452-375a67e1eccb}">
           <p14:sldIdLst>
             <p14:sldId id="263"/>
             <p14:sldId id="264"/>
@@ -152,20 +152,20 @@
             <p14:sldId id="269"/>
           </p14:sldIdLst>
         </p14:section>
-        <p14:section name="Übung" id="{fd893216-abb0-70f0-2bf3-5dffc441dc71}">
+        <p14:section name="Übung" id="{5c98ef55-8eb4-8772-89a4-7bd073e56a9a}">
           <p14:sldIdLst>
             <p14:sldId id="270"/>
             <p14:sldId id="271"/>
             <p14:sldId id="272"/>
           </p14:sldIdLst>
         </p14:section>
-        <p14:section name="Sicherung" id="{dfa0ec2f-51e1-61fd-3e8b-c549592b5097}">
+        <p14:section name="Sicherung" id="{897b77c6-db1a-ead6-0ff4-4734aa815faa}">
           <p14:sldIdLst>
             <p14:sldId id="273"/>
             <p14:sldId id="274"/>
           </p14:sldIdLst>
         </p14:section>
-        <p14:section name="Abschluss" id="{0f51d896-b48a-450c-7c0b-0364899836b6}">
+        <p14:section name="Abschluss" id="{c74c1ce8-52d4-c880-9483-8f59ff7401f6}">
           <p14:sldIdLst>
             <p14:sldId id="275"/>
           </p14:sldIdLst>
@@ -2573,6 +2573,45 @@
       </p:sp>
       <p:sp>
         <p:nvSpPr>
+          <p:cNvPr id="4" name="Text 1"/>
+          <p:cNvSpPr/>
+          <p:nvPr/>
+        </p:nvSpPr>
+        <p:spPr>
+          <a:xfrm>
+            <a:off x="7985455" y="6473952"/>
+            <a:ext cx="2926080" cy="274320"/>
+          </a:xfrm>
+          <a:prstGeom prst="rect">
+            <a:avLst/>
+          </a:prstGeom>
+          <a:noFill/>
+          <a:ln/>
+        </p:spPr>
+        <p:txBody>
+          <a:bodyPr wrap="square" lIns="0" tIns="0" rIns="0" bIns="0" rtlCol="0" anchor="ctr"/>
+          <a:lstStyle/>
+          <a:p>
+            <a:pPr algn="r" indent="0" marL="0">
+              <a:buNone/>
+            </a:pPr>
+            <a:r>
+              <a:rPr lang="en-US" sz="1100" dirty="0">
+                <a:solidFill>
+                  <a:srgbClr val="5B6770"/>
+                </a:solidFill>
+                <a:latin typeface="Calibri" pitchFamily="34" charset="0"/>
+                <a:ea typeface="Calibri" pitchFamily="34" charset="-122"/>
+                <a:cs typeface="Calibri" pitchFamily="34" charset="-120"/>
+              </a:rPr>
+              <a:t>CC BY-SA 4.0 · Frank Juchim</a:t>
+            </a:r>
+            <a:endParaRPr lang="en-US" sz="1100" dirty="0"/>
+          </a:p>
+        </p:txBody>
+      </p:sp>
+      <p:sp>
+        <p:nvSpPr>
           <p:cNvPr id="25" name="Slide Number Placeholder 0"/>
           <p:cNvSpPr>
             <a:spLocks noGrp="1"/>
@@ -2724,6 +2763,45 @@
                 <a:cs typeface="Calibri" pitchFamily="34" charset="-120"/>
               </a:rPr>
               <a:t>Level 1 · Welt A · Endliche Automaten · gA und eA</a:t>
+            </a:r>
+            <a:endParaRPr lang="en-US" sz="1100" dirty="0"/>
+          </a:p>
+        </p:txBody>
+      </p:sp>
+      <p:sp>
+        <p:nvSpPr>
+          <p:cNvPr id="4" name="Text 1"/>
+          <p:cNvSpPr/>
+          <p:nvPr/>
+        </p:nvSpPr>
+        <p:spPr>
+          <a:xfrm>
+            <a:off x="7985455" y="6473952"/>
+            <a:ext cx="2926080" cy="274320"/>
+          </a:xfrm>
+          <a:prstGeom prst="rect">
+            <a:avLst/>
+          </a:prstGeom>
+          <a:noFill/>
+          <a:ln/>
+        </p:spPr>
+        <p:txBody>
+          <a:bodyPr wrap="square" lIns="0" tIns="0" rIns="0" bIns="0" rtlCol="0" anchor="ctr"/>
+          <a:lstStyle/>
+          <a:p>
+            <a:pPr algn="r" indent="0" marL="0">
+              <a:buNone/>
+            </a:pPr>
+            <a:r>
+              <a:rPr lang="en-US" sz="1100" dirty="0">
+                <a:solidFill>
+                  <a:srgbClr val="5B6770"/>
+                </a:solidFill>
+                <a:latin typeface="Calibri" pitchFamily="34" charset="0"/>
+                <a:ea typeface="Calibri" pitchFamily="34" charset="-122"/>
+                <a:cs typeface="Calibri" pitchFamily="34" charset="-120"/>
+              </a:rPr>
+              <a:t>CC BY-SA 4.0 · Frank Juchim</a:t>
             </a:r>
             <a:endParaRPr lang="en-US" sz="1100" dirty="0"/>
           </a:p>

</xml_diff>